<commit_message>
Registra DEF-05 y DEF-06, agrega los casos de regresion y actualiza los entregables
- Plan de pruebas: DEF-05 y DEF-06 en el registro de defectos, casos de
  regresion CP-39 y CP-40, y los pendientes renumerados a CP-41..CP-47
- Metricas: densidad de 6 defectos en 12,941 lineas (0.46 por millar), 40 casos
  ejecutados y la leccion que dejan los dos defectos sobre probar cada modulo
  con un solo rol
- Documentacion funcional: el monitoreo tambien lo usan los administradores,
  eligiendo la estacion
- Se regeneran los cuatro PDF, la carta de aceptacion y el resumen ejecutivo

Co-Authored-By: Claude Opus 5 <noreply@anthropic.com>
</commit_message>
<xml_diff>
--- a/entregables/SIC_Transmetro_Resumen_Ejecutivo.pptx
+++ b/entregables/SIC_Transmetro_Resumen_Ejecutivo.pptx
@@ -118,32 +118,32 @@
   <p:extLst>
     <p:ext uri="{521415D9-36F7-43E2-AB2F-B90AF26B5E84}">
       <p14:sectionLst xmlns:p14="http://schemas.microsoft.com/office/powerpoint/2010/main">
-        <p14:section name="Apertura" id="{b01d75b6-cf0b-6997-f5b7-83bbd1841c8c}">
+        <p14:section name="Apertura" id="{cab56e1e-e529-8942-1f19-aaac6254b88b}">
           <p14:sldIdLst>
             <p14:sldId id="256"/>
           </p14:sldIdLst>
         </p14:section>
-        <p14:section name="El problema y la solución" id="{a76263a4-aa53-bbf0-ad7e-1faff811bc9c}">
+        <p14:section name="El problema y la solución" id="{c3f135dc-ab77-39a1-587e-3a2dd82a3bb0}">
           <p14:sldIdLst>
             <p14:sldId id="257"/>
             <p14:sldId id="258"/>
           </p14:sldIdLst>
         </p14:section>
-        <p14:section name="Lo construido" id="{fae8bdbe-8ed0-9a0b-0e4b-0c10fdda072d}">
+        <p14:section name="Lo construido" id="{6eeb8405-9400-1308-5fe7-20ca540e7803}">
           <p14:sldIdLst>
             <p14:sldId id="259"/>
             <p14:sldId id="260"/>
             <p14:sldId id="261"/>
           </p14:sldIdLst>
         </p14:section>
-        <p14:section name="Calidad y avance" id="{543510da-0f53-f5eb-6cd7-3f9e58033c22}">
+        <p14:section name="Calidad y avance" id="{2b138c18-3f80-551b-59ea-520444b78f3a}">
           <p14:sldIdLst>
             <p14:sldId id="262"/>
             <p14:sldId id="263"/>
             <p14:sldId id="264"/>
           </p14:sldIdLst>
         </p14:section>
-        <p14:section name="Cierre" id="{15bfa3a6-d171-31a8-dda0-899fb9d9bc98}">
+        <p14:section name="Cierre" id="{d9c1d1fd-cca8-3432-dfb4-25b70f16ba15}">
           <p14:sldIdLst>
             <p14:sldId id="265"/>
             <p14:sldId id="266"/>
@@ -4012,7 +4012,7 @@
                   <a:srgbClr val="3C4A5A"/>
                 </a:solidFill>
               </a:rPr>
-              <a:t>Los casos CP-27 a CP-38 se ejecutaron a mano. Sin automatizar, no se repiten solos en cada cambio.</a:t>
+              <a:t>Los casos CP-27 a CP-40 se ejecutaron a mano. DEF-05 y DEF-06 aparecieron justo ahí: en caminos que ninguna prueba recorre sola.</a:t>
             </a:r>
             <a:endParaRPr lang="en-US" sz="1200" dirty="0"/>
           </a:p>
@@ -4217,7 +4217,7 @@
                   <a:schemeClr val="tx2"/>
                 </a:solidFill>
               </a:rPr>
-              <a:t>Automatizar CP-27 a CP-38</a:t>
+              <a:t>Automatizar CP-27 a CP-40</a:t>
             </a:r>
             <a:endParaRPr lang="en-US" sz="1700" dirty="0"/>
           </a:p>
@@ -4253,7 +4253,7 @@
                   <a:srgbClr val="3C4A5A"/>
                 </a:solidFill>
               </a:rPr>
-              <a:t>Llevar a Vitest y Supertest los casos de monitoreo y personal, para que la regla de los cinco minutos y el sobrecupo se verifiquen en cada cambio.</a:t>
+              <a:t>Llevar a Vitest y Supertest los casos de monitoreo, personal y los dos de regresión, para que se verifiquen en cada cambio y no dependan de la memoria de quien prueba.</a:t>
             </a:r>
             <a:endParaRPr lang="en-US" sz="1300" dirty="0"/>
           </a:p>
@@ -5175,7 +5175,7 @@
                   <a:srgbClr val="9FBAD2"/>
                 </a:solidFill>
               </a:rPr>
-              <a:t>Documento unificado del proyecto: SIC_Transmetro_Documento_Unificado.pdf · 92 páginas · Partes I a V y anexo</a:t>
+              <a:t>Documento unificado del proyecto: SIC_Transmetro_Documento_Unificado.pdf · 93 páginas · Partes I a V y anexo</a:t>
             </a:r>
             <a:endParaRPr lang="en-US" sz="1300" dirty="0"/>
           </a:p>
@@ -8407,7 +8407,7 @@
                   <a:schemeClr val="accent5"/>
                 </a:solidFill>
               </a:rPr>
-              <a:t>38</a:t>
+              <a:t>40</a:t>
             </a:r>
             <a:endParaRPr lang="en-US" sz="4000" dirty="0"/>
           </a:p>
@@ -8515,7 +8515,7 @@
                   <a:srgbClr val="5A6B7D"/>
                 </a:solidFill>
               </a:rPr>
-              <a:t>12,941 líneas de código en 113 archivos · 15 pantallas · 4 defectos registrados, ninguno abierto</a:t>
+              <a:t>12,941 líneas de código en 113 archivos · 15 pantallas · 6 defectos registrados, ninguno abierto</a:t>
             </a:r>
             <a:endParaRPr lang="en-US" sz="1300" dirty="0"/>
           </a:p>
@@ -12867,7 +12867,7 @@
                           <a:ea typeface="Calibri" pitchFamily="34" charset="-122"/>
                           <a:cs typeface="Calibri" pitchFamily="34" charset="-120"/>
                         </a:rPr>
-                        <a:t>38 casos ejecutados</a:t>
+                        <a:t>40 casos ejecutados</a:t>
                       </a:r>
                       <a:endParaRPr lang="en-US" sz="1200" dirty="0">
                         <a:latin typeface="Calibri" charset="0"/>
@@ -13246,7 +13246,7 @@
                   <a:schemeClr val="accent1"/>
                 </a:solidFill>
               </a:rPr>
-              <a:t>38</a:t>
+              <a:t>40</a:t>
             </a:r>
             <a:endParaRPr lang="en-US" sz="4000" dirty="0"/>
           </a:p>
@@ -13318,7 +13318,7 @@
                   <a:srgbClr val="7A8899"/>
                 </a:solidFill>
               </a:rPr>
-              <a:t>CP-01 a CP-38</a:t>
+              <a:t>CP-01 a CP-40</a:t>
             </a:r>
             <a:endParaRPr lang="en-US" sz="1000" dirty="0"/>
           </a:p>
@@ -13388,7 +13388,7 @@
                   <a:schemeClr val="accent2"/>
                 </a:solidFill>
               </a:rPr>
-              <a:t>4</a:t>
+              <a:t>6</a:t>
             </a:r>
             <a:endParaRPr lang="en-US" sz="4000" dirty="0"/>
           </a:p>
@@ -13530,7 +13530,7 @@
                   <a:schemeClr val="accent2"/>
                 </a:solidFill>
               </a:rPr>
-              <a:t>0.31</a:t>
+              <a:t>0.46</a:t>
             </a:r>
             <a:endParaRPr lang="en-US" sz="4000" dirty="0"/>
           </a:p>
@@ -14208,7 +14208,7 @@
                   <a:srgbClr val="3C4A5A"/>
                 </a:solidFill>
               </a:rPr>
-              <a:t>El código aumentó 29 % y las pruebas automatizadas siguen en nueve. Automatizarlas es la primera tarea del sprint siguiente.</a:t>
+              <a:t>El código aumentó 29 % y las pruebas automatizadas siguen en nueve. Los defectos DEF-05 y DEF-06 aparecieron por ese hueco.</a:t>
             </a:r>
             <a:endParaRPr lang="en-US" sz="1250" dirty="0"/>
           </a:p>

</xml_diff>